<commit_message>
Preserve research fingerprints across Windows and Linux
Write the hash-protected master CSV with LF line endings, enforce portable checkout attributes, regenerate artifacts, and add a regression check for Git normalization.
</commit_message>
<xml_diff>
--- a/docs/presentation/maternal_mortality_research_briefing.pptx
+++ b/docs/presentation/maternal_mortality_research_briefing.pptx
@@ -7528,7 +7528,7 @@
           <a:lstStyle/>
           <a:p>
             <a:r>
-              <a:t>Source: reports/results.json; analytical CSV SHA-256 1dc945fec2030f3e21e5f47bd0ccfd31bc3dfbb036dcf9c070cc14213522e0e2</a:t>
+              <a:t>Source: reports/results.json; analytical CSV SHA-256 adb6de08142baa40051b4b54f2fd9c4fb821330db0a36ff68c7f50be8a31aed3</a:t>
             </a:r>
           </a:p>
           <a:p>
@@ -7613,7 +7613,7 @@
           <a:lstStyle/>
           <a:p>
             <a:r>
-              <a:t>Source: reports/results.json; analytical CSV SHA-256 1dc945fec2030f3e21e5f47bd0ccfd31bc3dfbb036dcf9c070cc14213522e0e2</a:t>
+              <a:t>Source: reports/results.json; analytical CSV SHA-256 adb6de08142baa40051b4b54f2fd9c4fb821330db0a36ff68c7f50be8a31aed3</a:t>
             </a:r>
           </a:p>
           <a:p>
@@ -7698,7 +7698,7 @@
           <a:lstStyle/>
           <a:p>
             <a:r>
-              <a:t>Source: reports/results.json; analytical CSV SHA-256 1dc945fec2030f3e21e5f47bd0ccfd31bc3dfbb036dcf9c070cc14213522e0e2</a:t>
+              <a:t>Source: reports/results.json; analytical CSV SHA-256 adb6de08142baa40051b4b54f2fd9c4fb821330db0a36ff68c7f50be8a31aed3</a:t>
             </a:r>
           </a:p>
           <a:p>
@@ -7783,7 +7783,7 @@
           <a:lstStyle/>
           <a:p>
             <a:r>
-              <a:t>Source: reports/results.json; analytical CSV SHA-256 1dc945fec2030f3e21e5f47bd0ccfd31bc3dfbb036dcf9c070cc14213522e0e2</a:t>
+              <a:t>Source: reports/results.json; analytical CSV SHA-256 adb6de08142baa40051b4b54f2fd9c4fb821330db0a36ff68c7f50be8a31aed3</a:t>
             </a:r>
           </a:p>
           <a:p>
@@ -7868,7 +7868,7 @@
           <a:lstStyle/>
           <a:p>
             <a:r>
-              <a:t>Source: reports/results.json; analytical CSV SHA-256 1dc945fec2030f3e21e5f47bd0ccfd31bc3dfbb036dcf9c070cc14213522e0e2</a:t>
+              <a:t>Source: reports/results.json; analytical CSV SHA-256 adb6de08142baa40051b4b54f2fd9c4fb821330db0a36ff68c7f50be8a31aed3</a:t>
             </a:r>
           </a:p>
           <a:p>
@@ -7953,7 +7953,7 @@
           <a:lstStyle/>
           <a:p>
             <a:r>
-              <a:t>Source: reports/results.json; analytical CSV SHA-256 1dc945fec2030f3e21e5f47bd0ccfd31bc3dfbb036dcf9c070cc14213522e0e2</a:t>
+              <a:t>Source: reports/results.json; analytical CSV SHA-256 adb6de08142baa40051b4b54f2fd9c4fb821330db0a36ff68c7f50be8a31aed3</a:t>
             </a:r>
           </a:p>
           <a:p>
@@ -8038,7 +8038,7 @@
           <a:lstStyle/>
           <a:p>
             <a:r>
-              <a:t>Source: reports/results.json; analytical CSV SHA-256 1dc945fec2030f3e21e5f47bd0ccfd31bc3dfbb036dcf9c070cc14213522e0e2</a:t>
+              <a:t>Source: reports/results.json; analytical CSV SHA-256 adb6de08142baa40051b4b54f2fd9c4fb821330db0a36ff68c7f50be8a31aed3</a:t>
             </a:r>
           </a:p>
           <a:p>
@@ -8123,7 +8123,7 @@
           <a:lstStyle/>
           <a:p>
             <a:r>
-              <a:t>Source: reports/results.json; analytical CSV SHA-256 1dc945fec2030f3e21e5f47bd0ccfd31bc3dfbb036dcf9c070cc14213522e0e2</a:t>
+              <a:t>Source: reports/results.json; analytical CSV SHA-256 adb6de08142baa40051b4b54f2fd9c4fb821330db0a36ff68c7f50be8a31aed3</a:t>
             </a:r>
           </a:p>
           <a:p>
@@ -8208,7 +8208,7 @@
           <a:lstStyle/>
           <a:p>
             <a:r>
-              <a:t>Source: reports/results.json; analytical CSV SHA-256 1dc945fec2030f3e21e5f47bd0ccfd31bc3dfbb036dcf9c070cc14213522e0e2</a:t>
+              <a:t>Source: reports/results.json; analytical CSV SHA-256 adb6de08142baa40051b4b54f2fd9c4fb821330db0a36ff68c7f50be8a31aed3</a:t>
             </a:r>
           </a:p>
           <a:p>
@@ -8293,7 +8293,7 @@
           <a:lstStyle/>
           <a:p>
             <a:r>
-              <a:t>Source: reports/results.json; analytical CSV SHA-256 1dc945fec2030f3e21e5f47bd0ccfd31bc3dfbb036dcf9c070cc14213522e0e2</a:t>
+              <a:t>Source: reports/results.json; analytical CSV SHA-256 adb6de08142baa40051b4b54f2fd9c4fb821330db0a36ff68c7f50be8a31aed3</a:t>
             </a:r>
           </a:p>
           <a:p>
@@ -8378,7 +8378,7 @@
           <a:lstStyle/>
           <a:p>
             <a:r>
-              <a:t>Source: reports/results.json; analytical CSV SHA-256 1dc945fec2030f3e21e5f47bd0ccfd31bc3dfbb036dcf9c070cc14213522e0e2</a:t>
+              <a:t>Source: reports/results.json; analytical CSV SHA-256 adb6de08142baa40051b4b54f2fd9c4fb821330db0a36ff68c7f50be8a31aed3</a:t>
             </a:r>
           </a:p>
           <a:p>
@@ -8463,7 +8463,7 @@
           <a:lstStyle/>
           <a:p>
             <a:r>
-              <a:t>Source: reports/results.json; analytical CSV SHA-256 1dc945fec2030f3e21e5f47bd0ccfd31bc3dfbb036dcf9c070cc14213522e0e2</a:t>
+              <a:t>Source: reports/results.json; analytical CSV SHA-256 adb6de08142baa40051b4b54f2fd9c4fb821330db0a36ff68c7f50be8a31aed3</a:t>
             </a:r>
           </a:p>
           <a:p>
@@ -8548,7 +8548,7 @@
           <a:lstStyle/>
           <a:p>
             <a:r>
-              <a:t>Source: reports/results.json; analytical CSV SHA-256 1dc945fec2030f3e21e5f47bd0ccfd31bc3dfbb036dcf9c070cc14213522e0e2</a:t>
+              <a:t>Source: reports/results.json; analytical CSV SHA-256 adb6de08142baa40051b4b54f2fd9c4fb821330db0a36ff68c7f50be8a31aed3</a:t>
             </a:r>
           </a:p>
           <a:p>
@@ -8633,7 +8633,7 @@
           <a:lstStyle/>
           <a:p>
             <a:r>
-              <a:t>Source: reports/results.json; analytical CSV SHA-256 1dc945fec2030f3e21e5f47bd0ccfd31bc3dfbb036dcf9c070cc14213522e0e2</a:t>
+              <a:t>Source: reports/results.json; analytical CSV SHA-256 adb6de08142baa40051b4b54f2fd9c4fb821330db0a36ff68c7f50be8a31aed3</a:t>
             </a:r>
           </a:p>
           <a:p>
@@ -8718,7 +8718,7 @@
           <a:lstStyle/>
           <a:p>
             <a:r>
-              <a:t>Source: reports/results.json; analytical CSV SHA-256 1dc945fec2030f3e21e5f47bd0ccfd31bc3dfbb036dcf9c070cc14213522e0e2</a:t>
+              <a:t>Source: reports/results.json; analytical CSV SHA-256 adb6de08142baa40051b4b54f2fd9c4fb821330db0a36ff68c7f50be8a31aed3</a:t>
             </a:r>
           </a:p>
           <a:p>

</xml_diff>